<commit_message>
Start scale chart at GPT-3.5 per review feedback
Chart window now opens at the ChatGPT era (late 2022) instead of GPT-1/2018;
headline stat updated to ~30x since GPT-3.5 (175B est. -> ~5T est.), with the
2018 arc retained as off-chart context in speaker notes and SOURCES.md.

Co-Authored-By: Claude Fable 5 <noreply@anthropic.com>
Claude-Session: https://claude.ai/code/session_01DhpgW8FRjbFsdQRofQCSWZ
</commit_message>
<xml_diff>
--- a/frontier-ai-deck/frontier-ai-scale-trajectory.pptx
+++ b/frontier-ai-deck/frontier-ai-scale-trajectory.pptx
@@ -592,7 +592,7 @@
           <a:p>
             <a:r>
               <a:rPr lang="en-US" dirty="0"/>
-              <a:t>SLIDE 2 - SCALE TRAJECTORY (the chart the room will remember). How to walk it: start bottom-left - GPT-1, 117M parameters, 2018, disclosed in the paper. Walk up the teal line: GPT-2 1.5B, GPT-3 175B (2020, the last disclosed OpenAI frontier count). Then the epistemics change: every point after 2020 is hollow - a third-party estimate with a range bar. GPT-4 ~1.8T total (SemiAnalysis leak; MoE, ~280B active per token). Orange line = Anthropic: RL-CAI 52B (disclosed in their research papers, Dec 2022), Claude 2 ~130B est., Claude 3 Opus ~2T est. (LifeArchitect), Claude 3.5 Sonnet ~400B est. (Epoch AI), Claude Opus 4.6 ~5T est. (third-party analysis; Musk claimed 5T), Claude Fable 5 ~10T widely cited but unconfirmed (dashed). KEY BEATS: (1) ~40,000x total-capacity growth 2018-&gt;2026 using mid estimates (117M -&gt; ~5T). (2) The 2024 dip is real and matters: both labs shipped smaller, cheaper frontier models (GPT-4o ~200B, 3.5 Sonnet ~400B) - scale is NOT monotonic; efficiency generations alternate with scale generations. (3) GPT-5.6: no credible size estimate exists yet - we show a dashed '?' range rather than invent one. (4) The violet band is OUR scenario (8-10T next-gen), not a forecast - note on log scale it is a small step above the rumored ~10T Mythos-class. HONESTY DETAILS if asked: ranges reflect the spread of published estimates, not lab guidance; Fable 5 and GPT-5.6 markers are nudged ~3 weeks apart horizontally so their range bars don't overlap (true dates Jun 9 / Jul 9, 2026); 'total capacity' counts all MoE experts - active-per-token counts are ~5-10x lower; independent Epoch analysis argues frontier models got SMALLER in 2023-24 before re-scaling. Sources: epoch.ai/gradient-updates/frontier-language-models-have-become-much-smaller; epoch.ai/publications/training-compute-of-frontier-ai-models-grows-by-4-5x-per-year; SemiAnalysis GPT-4 architecture report (Jul 2023); lifearchitect.ai (Claude estimates); press reports for GPT-4.5/GPT-5/Opus 4.6/Fable 5 figures.</a:t>
+              <a:t>SLIDE 2 - SCALE TRAJECTORY (the chart the room will remember). Window starts at the ChatGPT era per review feedback. How to walk it: bottom-left, GPT-3.5 (the ChatGPT launch model, Nov 2022) at ~175B est. - OpenAI never published a GPT-3.5 count, but it descends from GPT-3 (175B, disclosed 2020); its cheaper turbo variants were likely far smaller (a ~20B figure in a Microsoft paper was later retracted). Nearly every point in this window is hollow - a third-party estimate with a range bar. Teal = OpenAI: GPT-4 ~1.8T total (SemiAnalysis leak; MoE, ~280B active per token), GPT-4o ~200B est., GPT-4.5 ~4-5T est., GPT-5 ~3-5T est. Orange = Anthropic: RL-CAI 52B (disclosed in their research papers, Dec 2022 - the one filled dot), Claude 2 ~130B est., Claude 3 Opus ~2T est. (LifeArchitect), Claude 3.5 Sonnet ~400B est. (Epoch AI), Claude Opus 4.6 ~5T est. (third-party analysis; Musk claimed 5T), Claude Fable 5 ~10T widely cited but unconfirmed (dashed). Off-chart context if asked: the longer arc from GPT-1 (117M, 2018) to today's est. ~5T is roughly 40,000x in eight years. KEY BEATS: (1) ~30x total-capacity growth in under four years using mid estimates (GPT-3.5 ~175B, late 2022 -&gt; ~5T, 2026). (2) The 2024 dip is real and matters: both labs shipped smaller, cheaper frontier models (GPT-4o ~200B, 3.5 Sonnet ~400B) - scale is NOT monotonic; efficiency generations alternate with scale generations. (3) GPT-5.6: no credible size estimate exists yet - we show a dashed '?' range rather than invent one. (4) The violet band is OUR scenario (8-10T next-gen), not a forecast - note on log scale it is a small step above the rumored ~10T Mythos-class. HONESTY DETAILS if asked: ranges reflect the spread of published estimates, not lab guidance; Fable 5 and GPT-5.6 markers are nudged ~3 weeks apart horizontally so their range bars don't overlap (true dates Jun 9 / Jul 9, 2026); 'total capacity' counts all MoE experts - active-per-token counts are ~5-10x lower; independent Epoch analysis argues frontier models got SMALLER in 2023-24 before re-scaling. Sources: epoch.ai/gradient-updates/frontier-language-models-have-become-much-smaller; epoch.ai/publications/training-compute-of-frontier-ai-models-grows-by-4-5x-per-year; SemiAnalysis GPT-4 architecture report (Jul 2023); lifearchitect.ai (Claude estimates); press reports for GPT-4.5/GPT-5/Opus 4.6/Fable 5 figures.</a:t>
             </a:r>
             <a:endParaRPr lang="en-US" dirty="0"/>
           </a:p>
@@ -2010,7 +2010,7 @@
                 <a:ea typeface="Calibri" pitchFamily="34" charset="-122"/>
                 <a:cs typeface="Calibri" pitchFamily="34" charset="-120"/>
               </a:rPr>
-              <a:t>≈40,000× in eight years</a:t>
+              <a:t>≈30× since ChatGPT</a:t>
             </a:r>
             <a:pPr indent="0" marL="0">
               <a:buNone/>
@@ -2128,7 +2128,7 @@
                 <a:ea typeface="Calibri" pitchFamily="34" charset="-122"/>
                 <a:cs typeface="Calibri" pitchFamily="34" charset="-120"/>
               </a:rPr>
-              <a:t>OpenAI last disclosed a flagship count with GPT-3 (2020); Anthropic never has for Claude flagships. Filled dots = lab-disclosed; hollow dots = third-party estimates (bars = published ranges). MoE splits “total” vs “active”: GPT-4 est. ~1.8T total, ~280B active per token. Log scale: each gridline is 10×.  Sources: lab papers (GPT-1/2/3; RL-CAI 52B); SemiAnalysis (GPT-4); Epoch AI (GPT-4o, 3.5 Sonnet, compute trend); LifeArchitect (Claude 3 Opus); press/analyst reports (later flagships).</a:t>
+              <a:t>OpenAI last disclosed a flagship count with GPT-3 (2020); Anthropic never has for Claude flagships. Filled dots = lab-disclosed; hollow dots = third-party estimates (bars = published ranges). MoE splits “total” vs “active”: GPT-4 est. ~1.8T total, ~280B active per token. Log scale: each gridline is 10×.  Sources: lab papers (GPT-3 lineage for GPT-3.5; RL-CAI 52B); SemiAnalysis (GPT-4); Epoch AI (GPT-4o, 3.5 Sonnet, compute trend); LifeArchitect (Claude 3 Opus); press/analyst reports (later flagships).</a:t>
             </a:r>
             <a:endParaRPr lang="en-US" sz="900" dirty="0"/>
           </a:p>

</xml_diff>